<commit_message>
fix(figures): accelerate gallery previews and preserve native equation IDs
Refs: T-1697
</commit_message>
<xml_diff>
--- a/assets/paper-figures/20260925-restored-f02/Figure1_F02_editable.pptx
+++ b/assets/paper-figures/20260925-restored-f02/Figure1_F02_editable.pptx
@@ -19962,7 +19962,7 @@
         <mc:Choice Requires="a16">
           <p:sp>
             <p:nvSpPr>
-              <p:cNvPr id="2" name="Fhat_legend"/>
+              <p:cNvPr id="414" name="Fhat_legend"/>
               <p:cNvSpPr txBox="1"/>
               <p:nvPr/>
             </p:nvSpPr>
@@ -20248,7 +20248,7 @@
         <mc:Choice Requires="a16">
           <p:sp>
             <p:nvSpPr>
-              <p:cNvPr id="2" name="Fstar_legend"/>
+              <p:cNvPr id="417" name="Fstar_legend"/>
               <p:cNvSpPr txBox="1"/>
               <p:nvPr/>
             </p:nvSpPr>
@@ -20573,7 +20573,7 @@
         <mc:Choice Requires="a16">
           <p:sp>
             <p:nvSpPr>
-              <p:cNvPr id="2" name="budget"/>
+              <p:cNvPr id="420" name="budget"/>
               <p:cNvSpPr txBox="1"/>
               <p:nvPr/>
             </p:nvSpPr>
@@ -21713,7 +21713,7 @@
         <mc:Choice Requires="a16">
           <p:sp>
             <p:nvSpPr>
-              <p:cNvPr id="2" name="raw_dual"/>
+              <p:cNvPr id="430" name="raw_dual"/>
               <p:cNvSpPr txBox="1"/>
               <p:nvPr/>
             </p:nvSpPr>
@@ -22174,7 +22174,7 @@
         <mc:Choice Requires="a16">
           <p:sp>
             <p:nvSpPr>
-              <p:cNvPr id="2" name="feedback_cost"/>
+              <p:cNvPr id="434" name="feedback_cost"/>
               <p:cNvSpPr txBox="1"/>
               <p:nvPr/>
             </p:nvSpPr>
@@ -22933,7 +22933,7 @@
         <mc:Choice Requires="a16">
           <p:sp>
             <p:nvSpPr>
-              <p:cNvPr id="2" name="price_sum"/>
+              <p:cNvPr id="441" name="price_sum"/>
               <p:cNvSpPr txBox="1"/>
               <p:nvPr/>
             </p:nvSpPr>
@@ -24249,7 +24249,7 @@
         <mc:Choice Requires="a16">
           <p:sp>
             <p:nvSpPr>
-              <p:cNvPr id="2" name="priced_label"/>
+              <p:cNvPr id="452" name="priced_label"/>
               <p:cNvSpPr txBox="1"/>
               <p:nvPr/>
             </p:nvSpPr>
@@ -24549,7 +24549,7 @@
         <mc:Choice Requires="a16">
           <p:sp>
             <p:nvSpPr>
-              <p:cNvPr id="2" name="u_fixed_eq"/>
+              <p:cNvPr id="455" name="u_fixed_eq"/>
               <p:cNvSpPr txBox="1"/>
               <p:nvPr/>
             </p:nvSpPr>
@@ -26057,7 +26057,7 @@
         <mc:Choice Requires="a16">
           <p:sp>
             <p:nvSpPr>
-              <p:cNvPr id="2" name="u_lag_eq"/>
+              <p:cNvPr id="467" name="u_lag_eq"/>
               <p:cNvSpPr txBox="1"/>
               <p:nvPr/>
             </p:nvSpPr>
@@ -27980,7 +27980,7 @@
         <mc:Choice Requires="a16">
           <p:sp>
             <p:nvSpPr>
-              <p:cNvPr id="2" name="u_safe_eq"/>
+              <p:cNvPr id="482" name="u_safe_eq"/>
               <p:cNvSpPr txBox="1"/>
               <p:nvPr/>
             </p:nvSpPr>
@@ -29002,7 +29002,7 @@
         <mc:Choice Requires="a16">
           <p:sp>
             <p:nvSpPr>
-              <p:cNvPr id="2" name="u_lp_eq"/>
+              <p:cNvPr id="490" name="u_lp_eq"/>
               <p:cNvSpPr txBox="1"/>
               <p:nvPr/>
             </p:nvSpPr>

</xml_diff>